<commit_message>
Add header styling and improve table appearance
</commit_message>
<xml_diff>
--- a/examples/employees.pptx
+++ b/examples/employees.pptx
@@ -163,7 +163,7 @@
   </p:cSld>
   <p:clrMap bg1="lt1" tx1="dk1" bg2="lt2" tx2="dk2" accent1="accent1" accent2="accent2" accent3="accent3" accent4="accent4" accent5="accent5" accent6="accent6" hlink="hlink" folHlink="folHlink"/>
   <p:sldLayoutIdLst>
-    <p:sldLayoutId id="2471313794" r:id="rId1"/>
+    <p:sldLayoutId id="2471320712" r:id="rId1"/>
   </p:sldLayoutIdLst>
   <p:txStyles>
     <p:titleStyle>
@@ -307,7 +307,7 @@
                       <a:r>
                         <a:rPr lang="en-US" b="1" strike="noStrike" sz="1000" spc="0" u="none" cap="none">
                           <a:solidFill>
-                            <a:srgbClr val="000000">
+                            <a:srgbClr val="FFFFFF">
                               <a:alpha val="100000"/>
                             </a:srgbClr>
                           </a:solidFill>
@@ -376,7 +376,11 @@
                       <a:headEnd type="none" w="med" len="med"/>
                       <a:tailEnd type="none" w="med" len="med"/>
                     </a:lnBlToTr>
-                    <a:noFill/>
+                    <a:solidFill>
+                      <a:srgbClr val="4472C4">
+                        <a:alpha val="27000"/>
+                      </a:srgbClr>
+                    </a:solidFill>
                   </a:tcPr>
                 </a:tc>
                 <a:tc>
@@ -400,7 +404,7 @@
                       <a:r>
                         <a:rPr lang="en-US" b="1" strike="noStrike" sz="1000" spc="0" u="none" cap="none">
                           <a:solidFill>
-                            <a:srgbClr val="000000">
+                            <a:srgbClr val="FFFFFF">
                               <a:alpha val="100000"/>
                             </a:srgbClr>
                           </a:solidFill>
@@ -469,7 +473,11 @@
                       <a:headEnd type="none" w="med" len="med"/>
                       <a:tailEnd type="none" w="med" len="med"/>
                     </a:lnBlToTr>
-                    <a:noFill/>
+                    <a:solidFill>
+                      <a:srgbClr val="4472C4">
+                        <a:alpha val="27000"/>
+                      </a:srgbClr>
+                    </a:solidFill>
                   </a:tcPr>
                 </a:tc>
                 <a:tc>
@@ -493,7 +501,7 @@
                       <a:r>
                         <a:rPr lang="en-US" b="1" strike="noStrike" sz="1000" spc="0" u="none" cap="none">
                           <a:solidFill>
-                            <a:srgbClr val="000000">
+                            <a:srgbClr val="FFFFFF">
                               <a:alpha val="100000"/>
                             </a:srgbClr>
                           </a:solidFill>
@@ -562,7 +570,11 @@
                       <a:headEnd type="none" w="med" len="med"/>
                       <a:tailEnd type="none" w="med" len="med"/>
                     </a:lnBlToTr>
-                    <a:noFill/>
+                    <a:solidFill>
+                      <a:srgbClr val="4472C4">
+                        <a:alpha val="27000"/>
+                      </a:srgbClr>
+                    </a:solidFill>
                   </a:tcPr>
                 </a:tc>
               </a:tr>
@@ -687,7 +699,7 @@
                           </a:solidFill>
                           <a:latin typeface="Calibri"/>
                         </a:rPr>
-                        <a:t><![CDATA[27]]></a:t>
+                        <a:t><![CDATA[24]]></a:t>
                       </a:r>
                     </a:p>
                   </a:txBody>
@@ -968,7 +980,7 @@
                           </a:solidFill>
                           <a:latin typeface="Calibri"/>
                         </a:rPr>
-                        <a:t><![CDATA[22]]></a:t>
+                        <a:t><![CDATA[34]]></a:t>
                       </a:r>
                     </a:p>
                   </a:txBody>
@@ -1249,7 +1261,7 @@
                           </a:solidFill>
                           <a:latin typeface="Calibri"/>
                         </a:rPr>
-                        <a:t><![CDATA[27]]></a:t>
+                        <a:t><![CDATA[41]]></a:t>
                       </a:r>
                     </a:p>
                   </a:txBody>
@@ -1530,7 +1542,7 @@
                           </a:solidFill>
                           <a:latin typeface="Calibri"/>
                         </a:rPr>
-                        <a:t><![CDATA[22]]></a:t>
+                        <a:t><![CDATA[21]]></a:t>
                       </a:r>
                     </a:p>
                   </a:txBody>
@@ -1811,7 +1823,7 @@
                           </a:solidFill>
                           <a:latin typeface="Calibri"/>
                         </a:rPr>
-                        <a:t><![CDATA[22]]></a:t>
+                        <a:t><![CDATA[25]]></a:t>
                       </a:r>
                     </a:p>
                   </a:txBody>
@@ -2092,7 +2104,7 @@
                           </a:solidFill>
                           <a:latin typeface="Calibri"/>
                         </a:rPr>
-                        <a:t><![CDATA[46]]></a:t>
+                        <a:t><![CDATA[22]]></a:t>
                       </a:r>
                     </a:p>
                   </a:txBody>
@@ -2373,7 +2385,7 @@
                           </a:solidFill>
                           <a:latin typeface="Calibri"/>
                         </a:rPr>
-                        <a:t><![CDATA[24]]></a:t>
+                        <a:t><![CDATA[38]]></a:t>
                       </a:r>
                     </a:p>
                   </a:txBody>
@@ -2654,7 +2666,7 @@
                           </a:solidFill>
                           <a:latin typeface="Calibri"/>
                         </a:rPr>
-                        <a:t><![CDATA[37]]></a:t>
+                        <a:t><![CDATA[48]]></a:t>
                       </a:r>
                     </a:p>
                   </a:txBody>
@@ -2935,7 +2947,7 @@
                           </a:solidFill>
                           <a:latin typeface="Calibri"/>
                         </a:rPr>
-                        <a:t><![CDATA[36]]></a:t>
+                        <a:t><![CDATA[50]]></a:t>
                       </a:r>
                     </a:p>
                   </a:txBody>
@@ -3216,7 +3228,7 @@
                           </a:solidFill>
                           <a:latin typeface="Calibri"/>
                         </a:rPr>
-                        <a:t><![CDATA[50]]></a:t>
+                        <a:t><![CDATA[41]]></a:t>
                       </a:r>
                     </a:p>
                   </a:txBody>
@@ -3497,7 +3509,7 @@
                           </a:solidFill>
                           <a:latin typeface="Calibri"/>
                         </a:rPr>
-                        <a:t><![CDATA[36]]></a:t>
+                        <a:t><![CDATA[49]]></a:t>
                       </a:r>
                     </a:p>
                   </a:txBody>
@@ -3778,7 +3790,7 @@
                           </a:solidFill>
                           <a:latin typeface="Calibri"/>
                         </a:rPr>
-                        <a:t><![CDATA[29]]></a:t>
+                        <a:t><![CDATA[26]]></a:t>
                       </a:r>
                     </a:p>
                   </a:txBody>
@@ -4059,7 +4071,7 @@
                           </a:solidFill>
                           <a:latin typeface="Calibri"/>
                         </a:rPr>
-                        <a:t><![CDATA[50]]></a:t>
+                        <a:t><![CDATA[28]]></a:t>
                       </a:r>
                     </a:p>
                   </a:txBody>
@@ -4340,7 +4352,7 @@
                           </a:solidFill>
                           <a:latin typeface="Calibri"/>
                         </a:rPr>
-                        <a:t><![CDATA[38]]></a:t>
+                        <a:t><![CDATA[25]]></a:t>
                       </a:r>
                     </a:p>
                   </a:txBody>
@@ -4621,7 +4633,7 @@
                           </a:solidFill>
                           <a:latin typeface="Calibri"/>
                         </a:rPr>
-                        <a:t><![CDATA[40]]></a:t>
+                        <a:t><![CDATA[42]]></a:t>
                       </a:r>
                     </a:p>
                   </a:txBody>
@@ -4902,7 +4914,7 @@
                           </a:solidFill>
                           <a:latin typeface="Calibri"/>
                         </a:rPr>
-                        <a:t><![CDATA[43]]></a:t>
+                        <a:t><![CDATA[34]]></a:t>
                       </a:r>
                     </a:p>
                   </a:txBody>
@@ -5183,7 +5195,7 @@
                           </a:solidFill>
                           <a:latin typeface="Calibri"/>
                         </a:rPr>
-                        <a:t><![CDATA[35]]></a:t>
+                        <a:t><![CDATA[40]]></a:t>
                       </a:r>
                     </a:p>
                   </a:txBody>
@@ -5464,7 +5476,7 @@
                           </a:solidFill>
                           <a:latin typeface="Calibri"/>
                         </a:rPr>
-                        <a:t><![CDATA[43]]></a:t>
+                        <a:t><![CDATA[46]]></a:t>
                       </a:r>
                     </a:p>
                   </a:txBody>
@@ -5745,7 +5757,7 @@
                           </a:solidFill>
                           <a:latin typeface="Calibri"/>
                         </a:rPr>
-                        <a:t><![CDATA[48]]></a:t>
+                        <a:t><![CDATA[36]]></a:t>
                       </a:r>
                     </a:p>
                   </a:txBody>
@@ -6026,7 +6038,7 @@
                           </a:solidFill>
                           <a:latin typeface="Calibri"/>
                         </a:rPr>
-                        <a:t><![CDATA[38]]></a:t>
+                        <a:t><![CDATA[50]]></a:t>
                       </a:r>
                     </a:p>
                   </a:txBody>
@@ -6305,7 +6317,7 @@
                       <a:r>
                         <a:rPr lang="en-US" b="1" strike="noStrike" sz="1000" spc="0" u="none" cap="none">
                           <a:solidFill>
-                            <a:srgbClr val="000000">
+                            <a:srgbClr val="FFFFFF">
                               <a:alpha val="100000"/>
                             </a:srgbClr>
                           </a:solidFill>
@@ -6374,7 +6386,11 @@
                       <a:headEnd type="none" w="med" len="med"/>
                       <a:tailEnd type="none" w="med" len="med"/>
                     </a:lnBlToTr>
-                    <a:noFill/>
+                    <a:solidFill>
+                      <a:srgbClr val="4472C4">
+                        <a:alpha val="27000"/>
+                      </a:srgbClr>
+                    </a:solidFill>
                   </a:tcPr>
                 </a:tc>
                 <a:tc>
@@ -6398,7 +6414,7 @@
                       <a:r>
                         <a:rPr lang="en-US" b="1" strike="noStrike" sz="1000" spc="0" u="none" cap="none">
                           <a:solidFill>
-                            <a:srgbClr val="000000">
+                            <a:srgbClr val="FFFFFF">
                               <a:alpha val="100000"/>
                             </a:srgbClr>
                           </a:solidFill>
@@ -6467,7 +6483,11 @@
                       <a:headEnd type="none" w="med" len="med"/>
                       <a:tailEnd type="none" w="med" len="med"/>
                     </a:lnBlToTr>
-                    <a:noFill/>
+                    <a:solidFill>
+                      <a:srgbClr val="4472C4">
+                        <a:alpha val="27000"/>
+                      </a:srgbClr>
+                    </a:solidFill>
                   </a:tcPr>
                 </a:tc>
                 <a:tc>
@@ -6491,7 +6511,7 @@
                       <a:r>
                         <a:rPr lang="en-US" b="1" strike="noStrike" sz="1000" spc="0" u="none" cap="none">
                           <a:solidFill>
-                            <a:srgbClr val="000000">
+                            <a:srgbClr val="FFFFFF">
                               <a:alpha val="100000"/>
                             </a:srgbClr>
                           </a:solidFill>
@@ -6560,7 +6580,11 @@
                       <a:headEnd type="none" w="med" len="med"/>
                       <a:tailEnd type="none" w="med" len="med"/>
                     </a:lnBlToTr>
-                    <a:noFill/>
+                    <a:solidFill>
+                      <a:srgbClr val="4472C4">
+                        <a:alpha val="27000"/>
+                      </a:srgbClr>
+                    </a:solidFill>
                   </a:tcPr>
                 </a:tc>
               </a:tr>
@@ -6685,7 +6709,7 @@
                           </a:solidFill>
                           <a:latin typeface="Calibri"/>
                         </a:rPr>
-                        <a:t><![CDATA[48]]></a:t>
+                        <a:t><![CDATA[46]]></a:t>
                       </a:r>
                     </a:p>
                   </a:txBody>
@@ -6966,7 +6990,7 @@
                           </a:solidFill>
                           <a:latin typeface="Calibri"/>
                         </a:rPr>
-                        <a:t><![CDATA[24]]></a:t>
+                        <a:t><![CDATA[31]]></a:t>
                       </a:r>
                     </a:p>
                   </a:txBody>
@@ -7247,7 +7271,7 @@
                           </a:solidFill>
                           <a:latin typeface="Calibri"/>
                         </a:rPr>
-                        <a:t><![CDATA[40]]></a:t>
+                        <a:t><![CDATA[33]]></a:t>
                       </a:r>
                     </a:p>
                   </a:txBody>
@@ -7528,7 +7552,7 @@
                           </a:solidFill>
                           <a:latin typeface="Calibri"/>
                         </a:rPr>
-                        <a:t><![CDATA[49]]></a:t>
+                        <a:t><![CDATA[47]]></a:t>
                       </a:r>
                     </a:p>
                   </a:txBody>
@@ -7809,7 +7833,7 @@
                           </a:solidFill>
                           <a:latin typeface="Calibri"/>
                         </a:rPr>
-                        <a:t><![CDATA[30]]></a:t>
+                        <a:t><![CDATA[28]]></a:t>
                       </a:r>
                     </a:p>
                   </a:txBody>
@@ -8090,7 +8114,7 @@
                           </a:solidFill>
                           <a:latin typeface="Calibri"/>
                         </a:rPr>
-                        <a:t><![CDATA[26]]></a:t>
+                        <a:t><![CDATA[23]]></a:t>
                       </a:r>
                     </a:p>
                   </a:txBody>
@@ -8371,7 +8395,7 @@
                           </a:solidFill>
                           <a:latin typeface="Calibri"/>
                         </a:rPr>
-                        <a:t><![CDATA[38]]></a:t>
+                        <a:t><![CDATA[22]]></a:t>
                       </a:r>
                     </a:p>
                   </a:txBody>
@@ -8652,7 +8676,7 @@
                           </a:solidFill>
                           <a:latin typeface="Calibri"/>
                         </a:rPr>
-                        <a:t><![CDATA[37]]></a:t>
+                        <a:t><![CDATA[22]]></a:t>
                       </a:r>
                     </a:p>
                   </a:txBody>
@@ -8933,7 +8957,7 @@
                           </a:solidFill>
                           <a:latin typeface="Calibri"/>
                         </a:rPr>
-                        <a:t><![CDATA[24]]></a:t>
+                        <a:t><![CDATA[33]]></a:t>
                       </a:r>
                     </a:p>
                   </a:txBody>
@@ -9214,7 +9238,7 @@
                           </a:solidFill>
                           <a:latin typeface="Calibri"/>
                         </a:rPr>
-                        <a:t><![CDATA[21]]></a:t>
+                        <a:t><![CDATA[25]]></a:t>
                       </a:r>
                     </a:p>
                   </a:txBody>
@@ -9495,7 +9519,7 @@
                           </a:solidFill>
                           <a:latin typeface="Calibri"/>
                         </a:rPr>
-                        <a:t><![CDATA[27]]></a:t>
+                        <a:t><![CDATA[25]]></a:t>
                       </a:r>
                     </a:p>
                   </a:txBody>
@@ -9776,7 +9800,7 @@
                           </a:solidFill>
                           <a:latin typeface="Calibri"/>
                         </a:rPr>
-                        <a:t><![CDATA[50]]></a:t>
+                        <a:t><![CDATA[41]]></a:t>
                       </a:r>
                     </a:p>
                   </a:txBody>
@@ -10057,7 +10081,7 @@
                           </a:solidFill>
                           <a:latin typeface="Calibri"/>
                         </a:rPr>
-                        <a:t><![CDATA[40]]></a:t>
+                        <a:t><![CDATA[47]]></a:t>
                       </a:r>
                     </a:p>
                   </a:txBody>
@@ -10338,7 +10362,7 @@
                           </a:solidFill>
                           <a:latin typeface="Calibri"/>
                         </a:rPr>
-                        <a:t><![CDATA[41]]></a:t>
+                        <a:t><![CDATA[33]]></a:t>
                       </a:r>
                     </a:p>
                   </a:txBody>
@@ -10619,7 +10643,7 @@
                           </a:solidFill>
                           <a:latin typeface="Calibri"/>
                         </a:rPr>
-                        <a:t><![CDATA[40]]></a:t>
+                        <a:t><![CDATA[45]]></a:t>
                       </a:r>
                     </a:p>
                   </a:txBody>
@@ -10900,7 +10924,7 @@
                           </a:solidFill>
                           <a:latin typeface="Calibri"/>
                         </a:rPr>
-                        <a:t><![CDATA[32]]></a:t>
+                        <a:t><![CDATA[35]]></a:t>
                       </a:r>
                     </a:p>
                   </a:txBody>
@@ -11181,7 +11205,7 @@
                           </a:solidFill>
                           <a:latin typeface="Calibri"/>
                         </a:rPr>
-                        <a:t><![CDATA[36]]></a:t>
+                        <a:t><![CDATA[34]]></a:t>
                       </a:r>
                     </a:p>
                   </a:txBody>
@@ -11462,7 +11486,7 @@
                           </a:solidFill>
                           <a:latin typeface="Calibri"/>
                         </a:rPr>
-                        <a:t><![CDATA[49]]></a:t>
+                        <a:t><![CDATA[35]]></a:t>
                       </a:r>
                     </a:p>
                   </a:txBody>
@@ -11743,7 +11767,7 @@
                           </a:solidFill>
                           <a:latin typeface="Calibri"/>
                         </a:rPr>
-                        <a:t><![CDATA[31]]></a:t>
+                        <a:t><![CDATA[42]]></a:t>
                       </a:r>
                     </a:p>
                   </a:txBody>
@@ -12024,7 +12048,7 @@
                           </a:solidFill>
                           <a:latin typeface="Calibri"/>
                         </a:rPr>
-                        <a:t><![CDATA[28]]></a:t>
+                        <a:t><![CDATA[40]]></a:t>
                       </a:r>
                     </a:p>
                   </a:txBody>
@@ -12303,7 +12327,7 @@
                       <a:r>
                         <a:rPr lang="en-US" b="1" strike="noStrike" sz="1000" spc="0" u="none" cap="none">
                           <a:solidFill>
-                            <a:srgbClr val="000000">
+                            <a:srgbClr val="FFFFFF">
                               <a:alpha val="100000"/>
                             </a:srgbClr>
                           </a:solidFill>
@@ -12372,7 +12396,11 @@
                       <a:headEnd type="none" w="med" len="med"/>
                       <a:tailEnd type="none" w="med" len="med"/>
                     </a:lnBlToTr>
-                    <a:noFill/>
+                    <a:solidFill>
+                      <a:srgbClr val="4472C4">
+                        <a:alpha val="27000"/>
+                      </a:srgbClr>
+                    </a:solidFill>
                   </a:tcPr>
                 </a:tc>
                 <a:tc>
@@ -12396,7 +12424,7 @@
                       <a:r>
                         <a:rPr lang="en-US" b="1" strike="noStrike" sz="1000" spc="0" u="none" cap="none">
                           <a:solidFill>
-                            <a:srgbClr val="000000">
+                            <a:srgbClr val="FFFFFF">
                               <a:alpha val="100000"/>
                             </a:srgbClr>
                           </a:solidFill>
@@ -12465,7 +12493,11 @@
                       <a:headEnd type="none" w="med" len="med"/>
                       <a:tailEnd type="none" w="med" len="med"/>
                     </a:lnBlToTr>
-                    <a:noFill/>
+                    <a:solidFill>
+                      <a:srgbClr val="4472C4">
+                        <a:alpha val="27000"/>
+                      </a:srgbClr>
+                    </a:solidFill>
                   </a:tcPr>
                 </a:tc>
                 <a:tc>
@@ -12489,7 +12521,7 @@
                       <a:r>
                         <a:rPr lang="en-US" b="1" strike="noStrike" sz="1000" spc="0" u="none" cap="none">
                           <a:solidFill>
-                            <a:srgbClr val="000000">
+                            <a:srgbClr val="FFFFFF">
                               <a:alpha val="100000"/>
                             </a:srgbClr>
                           </a:solidFill>
@@ -12558,7 +12590,11 @@
                       <a:headEnd type="none" w="med" len="med"/>
                       <a:tailEnd type="none" w="med" len="med"/>
                     </a:lnBlToTr>
-                    <a:noFill/>
+                    <a:solidFill>
+                      <a:srgbClr val="4472C4">
+                        <a:alpha val="27000"/>
+                      </a:srgbClr>
+                    </a:solidFill>
                   </a:tcPr>
                 </a:tc>
               </a:tr>
@@ -12683,7 +12719,7 @@
                           </a:solidFill>
                           <a:latin typeface="Calibri"/>
                         </a:rPr>
-                        <a:t><![CDATA[42]]></a:t>
+                        <a:t><![CDATA[45]]></a:t>
                       </a:r>
                     </a:p>
                   </a:txBody>
@@ -12964,7 +13000,7 @@
                           </a:solidFill>
                           <a:latin typeface="Calibri"/>
                         </a:rPr>
-                        <a:t><![CDATA[42]]></a:t>
+                        <a:t><![CDATA[41]]></a:t>
                       </a:r>
                     </a:p>
                   </a:txBody>
@@ -13245,7 +13281,7 @@
                           </a:solidFill>
                           <a:latin typeface="Calibri"/>
                         </a:rPr>
-                        <a:t><![CDATA[34]]></a:t>
+                        <a:t><![CDATA[27]]></a:t>
                       </a:r>
                     </a:p>
                   </a:txBody>
@@ -13526,7 +13562,7 @@
                           </a:solidFill>
                           <a:latin typeface="Calibri"/>
                         </a:rPr>
-                        <a:t><![CDATA[47]]></a:t>
+                        <a:t><![CDATA[35]]></a:t>
                       </a:r>
                     </a:p>
                   </a:txBody>
@@ -13807,7 +13843,7 @@
                           </a:solidFill>
                           <a:latin typeface="Calibri"/>
                         </a:rPr>
-                        <a:t><![CDATA[22]]></a:t>
+                        <a:t><![CDATA[32]]></a:t>
                       </a:r>
                     </a:p>
                   </a:txBody>
@@ -14088,7 +14124,7 @@
                           </a:solidFill>
                           <a:latin typeface="Calibri"/>
                         </a:rPr>
-                        <a:t><![CDATA[30]]></a:t>
+                        <a:t><![CDATA[48]]></a:t>
                       </a:r>
                     </a:p>
                   </a:txBody>
@@ -14369,7 +14405,7 @@
                           </a:solidFill>
                           <a:latin typeface="Calibri"/>
                         </a:rPr>
-                        <a:t><![CDATA[24]]></a:t>
+                        <a:t><![CDATA[25]]></a:t>
                       </a:r>
                     </a:p>
                   </a:txBody>
@@ -14650,7 +14686,7 @@
                           </a:solidFill>
                           <a:latin typeface="Calibri"/>
                         </a:rPr>
-                        <a:t><![CDATA[38]]></a:t>
+                        <a:t><![CDATA[21]]></a:t>
                       </a:r>
                     </a:p>
                   </a:txBody>
@@ -14931,7 +14967,7 @@
                           </a:solidFill>
                           <a:latin typeface="Calibri"/>
                         </a:rPr>
-                        <a:t><![CDATA[45]]></a:t>
+                        <a:t><![CDATA[27]]></a:t>
                       </a:r>
                     </a:p>
                   </a:txBody>
@@ -15212,7 +15248,7 @@
                           </a:solidFill>
                           <a:latin typeface="Calibri"/>
                         </a:rPr>
-                        <a:t><![CDATA[41]]></a:t>
+                        <a:t><![CDATA[46]]></a:t>
                       </a:r>
                     </a:p>
                   </a:txBody>
@@ -15493,7 +15529,7 @@
                           </a:solidFill>
                           <a:latin typeface="Calibri"/>
                         </a:rPr>
-                        <a:t><![CDATA[32]]></a:t>
+                        <a:t><![CDATA[40]]></a:t>
                       </a:r>
                     </a:p>
                   </a:txBody>
@@ -15774,7 +15810,7 @@
                           </a:solidFill>
                           <a:latin typeface="Calibri"/>
                         </a:rPr>
-                        <a:t><![CDATA[20]]></a:t>
+                        <a:t><![CDATA[40]]></a:t>
                       </a:r>
                     </a:p>
                   </a:txBody>
@@ -16055,7 +16091,7 @@
                           </a:solidFill>
                           <a:latin typeface="Calibri"/>
                         </a:rPr>
-                        <a:t><![CDATA[25]]></a:t>
+                        <a:t><![CDATA[43]]></a:t>
                       </a:r>
                     </a:p>
                   </a:txBody>
@@ -16336,7 +16372,7 @@
                           </a:solidFill>
                           <a:latin typeface="Calibri"/>
                         </a:rPr>
-                        <a:t><![CDATA[43]]></a:t>
+                        <a:t><![CDATA[41]]></a:t>
                       </a:r>
                     </a:p>
                   </a:txBody>
@@ -16617,7 +16653,7 @@
                           </a:solidFill>
                           <a:latin typeface="Calibri"/>
                         </a:rPr>
-                        <a:t><![CDATA[24]]></a:t>
+                        <a:t><![CDATA[33]]></a:t>
                       </a:r>
                     </a:p>
                   </a:txBody>
@@ -16790,9 +16826,9 @@
 </file>
 
 <file path=ppt/theme/theme1.xml><?xml version="1.0" encoding="utf-8"?>
-<a:theme xmlns:a="http://schemas.openxmlformats.org/drawingml/2006/main" name="Theme86">
+<a:theme xmlns:a="http://schemas.openxmlformats.org/drawingml/2006/main" name="Theme53">
   <a:themeElements>
-    <a:clrScheme name="Theme86">
+    <a:clrScheme name="Theme53">
       <a:dk1>
         <a:sysClr val="windowText" lastClr="000000"/>
       </a:dk1>
@@ -16830,7 +16866,7 @@
         <a:srgbClr val="800080"/>
       </a:folHlink>
     </a:clrScheme>
-    <a:fontScheme name="Theme86">
+    <a:fontScheme name="Theme53">
       <a:majorFont>
         <a:latin typeface="Calibri"/>
         <a:ea typeface=""/>
@@ -16900,7 +16936,7 @@
         <a:font script="Uigh" typeface="Microsoft Uighur"/>
       </a:minorFont>
     </a:fontScheme>
-    <a:fmtScheme name="Theme86">
+    <a:fmtScheme name="Theme53">
       <a:fillStyleLst>
         <a:solidFill>
           <a:schemeClr val="phClr"/>

</xml_diff>